<commit_message>
Fill in real team info: Lu Lu and Yiyan
Replaced every [Name] placeholder across the one-pager, the pitch deck (Team
slide + closing slide), and the 2-min script's speaker notes:
- Lu Lu: Wharton MBA, Penn M.S. Computer Science, PM intern at Adobe
- Yiyan: go-to-market & growth

No more placeholder text blocking submission on the team front. Validated
both regenerated files (docx XML, pptx structural validation) before commit.
</commit_message>
<xml_diff>
--- a/pitch_deck/ClearBill_AI_Pitch_Deck.pptx
+++ b/pitch_deck/ClearBill_AI_Pitch_Deck.pptx
@@ -686,7 +686,7 @@
           <a:p>
             <a:r>
               <a:rPr lang="en-US" dirty="0"/>
-              <a:t>[0:10-0:22 TEAM] I'm [Name], [background]. This is [Name], [background]. We built ClearBill AI this weekend because we wanted something we'd actually trust our own families to use the next time a bill like this showed up.</a:t>
+              <a:t>[0:10-0:22 TEAM] I'm Lu Lu — Wharton MBA and a Master's in Computer Science from Penn, and I've been a product management intern at Adobe. This is Yiyan, who's leading our go-to-market strategy. We built ClearBill AI this weekend because we wanted something we'd actually trust our own families to use the next time a bill like this showed up.</a:t>
             </a:r>
             <a:endParaRPr lang="en-US" dirty="0"/>
           </a:p>
@@ -2533,7 +2533,7 @@
                 <a:ea typeface="Cambria" pitchFamily="34" charset="-122"/>
                 <a:cs typeface="Cambria" pitchFamily="34" charset="-120"/>
               </a:rPr>
-              <a:t>N</a:t>
+              <a:t>LL</a:t>
             </a:r>
             <a:endParaRPr lang="en-US" sz="2400" dirty="0"/>
           </a:p>
@@ -2572,7 +2572,7 @@
                 <a:ea typeface="Cambria" pitchFamily="34" charset="-122"/>
                 <a:cs typeface="Cambria" pitchFamily="34" charset="-120"/>
               </a:rPr>
-              <a:t>[Name]</a:t>
+              <a:t>Lu Lu</a:t>
             </a:r>
             <a:endParaRPr lang="en-US" sz="1900" dirty="0"/>
           </a:p>
@@ -2614,7 +2614,7 @@
                 <a:ea typeface="Calibri" pitchFamily="34" charset="-122"/>
                 <a:cs typeface="Calibri" pitchFamily="34" charset="-120"/>
               </a:rPr>
-              <a:t>[Role — one line of relevant background]</a:t>
+              <a:t>Wharton MBA · Penn M.S. Computer Science · PM intern, Adobe</a:t>
             </a:r>
             <a:endParaRPr lang="en-US" sz="1300" dirty="0"/>
           </a:p>
@@ -2673,7 +2673,7 @@
                 <a:ea typeface="Cambria" pitchFamily="34" charset="-122"/>
                 <a:cs typeface="Cambria" pitchFamily="34" charset="-120"/>
               </a:rPr>
-              <a:t>N</a:t>
+              <a:t>Y</a:t>
             </a:r>
             <a:endParaRPr lang="en-US" sz="2400" dirty="0"/>
           </a:p>
@@ -2712,7 +2712,7 @@
                 <a:ea typeface="Cambria" pitchFamily="34" charset="-122"/>
                 <a:cs typeface="Cambria" pitchFamily="34" charset="-120"/>
               </a:rPr>
-              <a:t>[Name]</a:t>
+              <a:t>Yiyan</a:t>
             </a:r>
             <a:endParaRPr lang="en-US" sz="1900" dirty="0"/>
           </a:p>
@@ -2754,7 +2754,7 @@
                 <a:ea typeface="Calibri" pitchFamily="34" charset="-122"/>
                 <a:cs typeface="Calibri" pitchFamily="34" charset="-120"/>
               </a:rPr>
-              <a:t>[Role — one line of relevant background]</a:t>
+              <a:t>Go-to-market &amp; growth</a:t>
             </a:r>
             <a:endParaRPr lang="en-US" sz="1300" dirty="0"/>
           </a:p>
@@ -8801,7 +8801,7 @@
                 <a:ea typeface="Calibri" pitchFamily="34" charset="-122"/>
                 <a:cs typeface="Calibri" pitchFamily="34" charset="-120"/>
               </a:rPr>
-              <a:t>[Name] · [Name]</a:t>
+              <a:t>Lu Lu · Yiyan</a:t>
             </a:r>
             <a:endParaRPr lang="en-US" sz="1500" dirty="0"/>
           </a:p>

</xml_diff>